<commit_message>
Remove rotulos de nomes tambem das copias avulsas de Aula01 e Aula02
</commit_message>
<xml_diff>
--- a/Aula01_Introducao_a_Computacao_e_ao_Pensamento_Computacional/Aula01_Teoria-.pptx
+++ b/Aula01_Introducao_a_Computacao_e_ao_Pensamento_Computacional/Aula01_Teoria-.pptx
@@ -4214,7 +4214,7 @@
                 <a:latin typeface="Aptos"/>
                 <a:ea typeface="Aptos"/>
               </a:rPr>
-              <a:t>• Relato: deslocar foco da ferramenta para a tarefa.</a:t>
+              <a:t>Deslocar foco da ferramenta para a tarefa.</a:t>
             </a:r>
             <a:endParaRPr b="0" lang="pt-BR" sz="1200" strike="noStrike" u="none">
               <a:solidFill>
@@ -4241,7 +4241,7 @@
                 <a:latin typeface="Aptos"/>
                 <a:ea typeface="Aptos"/>
               </a:rPr>
-              <a:t>• Wessels: organizar dados é componente crítico da representação.</a:t>
+              <a:t>Organizar dados é componente crítico da representação.</a:t>
             </a:r>
             <a:endParaRPr b="0" lang="pt-BR" sz="1200" strike="noStrike" u="none">
               <a:solidFill>
@@ -4268,7 +4268,7 @@
                 <a:latin typeface="Aptos"/>
                 <a:ea typeface="Aptos"/>
               </a:rPr>
-              <a:t>• Queiroz: o resultado final não esgota a aprendizagem do conceito.</a:t>
+              <a:t>O resultado final não esgota a aprendizagem do conceito.</a:t>
             </a:r>
             <a:endParaRPr b="0" lang="pt-BR" sz="1200" strike="noStrike" u="none">
               <a:solidFill>
@@ -5424,7 +5424,7 @@
                 <a:latin typeface="Aptos"/>
                 <a:ea typeface="Aptos"/>
               </a:rPr>
-              <a:t>• Relato: explicitar variáveis, relações e restrições.</a:t>
+              <a:t>Explicitar variáveis, relações e restrições.</a:t>
             </a:r>
             <a:endParaRPr b="0" lang="pt-BR" sz="1050" strike="noStrike" u="none">
               <a:solidFill>
@@ -5451,7 +5451,7 @@
                 <a:latin typeface="Aptos"/>
                 <a:ea typeface="Aptos"/>
               </a:rPr>
-              <a:t>• Queiroz: representações ampliam a percepção de propriedades e relações.</a:t>
+              <a:t>Representações ampliam a percepção de propriedades e relações.</a:t>
             </a:r>
             <a:endParaRPr b="0" lang="pt-BR" sz="1050" strike="noStrike" u="none">
               <a:solidFill>
@@ -5478,7 +5478,7 @@
                 <a:latin typeface="Aptos"/>
                 <a:ea typeface="Aptos"/>
               </a:rPr>
-              <a:t>• Wessels: o contexto e o tipo de dado influenciam a representação escolhida.</a:t>
+              <a:t>O contexto e o tipo de dado influenciam a representação escolhida.</a:t>
             </a:r>
             <a:endParaRPr b="0" lang="pt-BR" sz="1050" strike="noStrike" u="none">
               <a:solidFill>
@@ -6634,7 +6634,7 @@
                 <a:latin typeface="Aptos"/>
                 <a:ea typeface="Aptos"/>
               </a:rPr>
-              <a:t>• Wessels: organizar dados é componente crítico da representação.</a:t>
+              <a:t>Organizar dados é componente crítico da representação.</a:t>
             </a:r>
             <a:endParaRPr b="0" lang="pt-BR" sz="1100" strike="noStrike" u="none">
               <a:solidFill>
@@ -6661,7 +6661,7 @@
                 <a:latin typeface="Aptos"/>
                 <a:ea typeface="Aptos"/>
               </a:rPr>
-              <a:t>• Queiroz: múltiplas expressões exibem aspectos distintos do mesmo conceito.</a:t>
+              <a:t>Múltiplas expressões exibem aspectos distintos do mesmo conceito.</a:t>
             </a:r>
             <a:endParaRPr b="0" lang="pt-BR" sz="1100" strike="noStrike" u="none">
               <a:solidFill>
@@ -6688,7 +6688,7 @@
                 <a:latin typeface="Aptos"/>
                 <a:ea typeface="Aptos"/>
               </a:rPr>
-              <a:t>• Relato: articular código, texto, tabela, gráfico e interpretação.</a:t>
+              <a:t>Articular código, texto, tabela, gráfico e interpretação.</a:t>
             </a:r>
             <a:endParaRPr b="0" lang="pt-BR" sz="1100" strike="noStrike" u="none">
               <a:solidFill>
@@ -7844,7 +7844,7 @@
                 <a:latin typeface="Aptos"/>
                 <a:ea typeface="Aptos"/>
               </a:rPr>
-              <a:t>• Relato: permitir manipulação de parâmetros e comparação de estados.</a:t>
+              <a:t>Permitir manipulação de parâmetros e comparação de estados.</a:t>
             </a:r>
             <a:endParaRPr b="0" lang="pt-BR" sz="1050" strike="noStrike" u="none">
               <a:solidFill>
@@ -7871,7 +7871,7 @@
                 <a:latin typeface="Aptos"/>
                 <a:ea typeface="Aptos"/>
               </a:rPr>
-              <a:t>• Queiroz: a interação consciente com a forma favorece reflexão conceitual.</a:t>
+              <a:t>A interação consciente com a forma favorece reflexão conceitual.</a:t>
             </a:r>
             <a:endParaRPr b="0" lang="pt-BR" sz="1050" strike="noStrike" u="none">
               <a:solidFill>
@@ -7898,7 +7898,7 @@
                 <a:latin typeface="Aptos"/>
                 <a:ea typeface="Aptos"/>
               </a:rPr>
-              <a:t>• Wessels: múltiplas representações indicam modelagem mais bem-sucedida.</a:t>
+              <a:t>Múltiplas representações indicam modelagem mais bem-sucedida.</a:t>
             </a:r>
             <a:endParaRPr b="0" lang="pt-BR" sz="1050" strike="noStrike" u="none">
               <a:solidFill>
@@ -9024,7 +9024,7 @@
                 <a:latin typeface="Aptos"/>
                 <a:ea typeface="Aptos"/>
               </a:rPr>
-              <a:t>• Wessels: múltiplas representações indicam modelagem mais bem-sucedida.</a:t>
+              <a:t>Múltiplas representações indicam modelagem mais bem-sucedida.</a:t>
             </a:r>
             <a:endParaRPr b="0" lang="pt-BR" sz="1050" strike="noStrike" u="none">
               <a:solidFill>
@@ -9051,7 +9051,7 @@
                 <a:latin typeface="Aptos"/>
                 <a:ea typeface="Aptos"/>
               </a:rPr>
-              <a:t>• Queiroz: múltiplas expressões exibem aspectos distintos do mesmo conceito.</a:t>
+              <a:t>Múltiplas expressões exibem aspectos distintos do mesmo conceito.</a:t>
             </a:r>
             <a:endParaRPr b="0" lang="pt-BR" sz="1050" strike="noStrike" u="none">
               <a:solidFill>
@@ -9078,7 +9078,7 @@
                 <a:latin typeface="Aptos"/>
                 <a:ea typeface="Aptos"/>
               </a:rPr>
-              <a:t>• Relato: articular código, texto, tabela, gráfico e interpretação.</a:t>
+              <a:t>Articular código, texto, tabela, gráfico e interpretação.</a:t>
             </a:r>
             <a:endParaRPr b="0" lang="pt-BR" sz="1050" strike="noStrike" u="none">
               <a:solidFill>
@@ -10234,7 +10234,7 @@
                 <a:latin typeface="Aptos"/>
                 <a:ea typeface="Aptos"/>
               </a:rPr>
-              <a:t>• Wessels: transnumeração torna dados interpretáveis em nova forma.</a:t>
+              <a:t>Transnumeração torna dados interpretáveis em nova forma.</a:t>
             </a:r>
             <a:endParaRPr b="0" lang="pt-BR" sz="1050" strike="noStrike" u="none">
               <a:solidFill>
@@ -10261,7 +10261,7 @@
                 <a:latin typeface="Aptos"/>
                 <a:ea typeface="Aptos"/>
               </a:rPr>
-              <a:t>• Queiroz: representações ampliam a percepção de propriedades e relações.</a:t>
+              <a:t>Representações ampliam a percepção de propriedades e relações.</a:t>
             </a:r>
             <a:endParaRPr b="0" lang="pt-BR" sz="1050" strike="noStrike" u="none">
               <a:solidFill>
@@ -10288,7 +10288,7 @@
                 <a:latin typeface="Aptos"/>
                 <a:ea typeface="Aptos"/>
               </a:rPr>
-              <a:t>• Relato: solicitar explicação do raciocínio desenvolvido.</a:t>
+              <a:t>Solicitar explicação do raciocínio desenvolvido.</a:t>
             </a:r>
             <a:endParaRPr b="0" lang="pt-BR" sz="1050" strike="noStrike" u="none">
               <a:solidFill>
@@ -11444,7 +11444,7 @@
                 <a:latin typeface="Aptos"/>
                 <a:ea typeface="Aptos"/>
               </a:rPr>
-              <a:t>• Wessels: níveis SOLO ajudam a observar respostas de menor a maior integração.</a:t>
+              <a:t>Níveis SOLO ajudam a observar respostas de menor a maior integração.</a:t>
             </a:r>
             <a:endParaRPr b="0" lang="pt-BR" sz="1100" strike="noStrike" u="none">
               <a:solidFill>
@@ -11471,7 +11471,7 @@
                 <a:latin typeface="Aptos"/>
                 <a:ea typeface="Aptos"/>
               </a:rPr>
-              <a:t>• Queiroz: a análise qualitativa observa invariantes e relações mobilizadas na ação.</a:t>
+              <a:t>A análise qualitativa observa invariantes e relações mobilizadas na ação.</a:t>
             </a:r>
             <a:endParaRPr b="0" lang="pt-BR" sz="1100" strike="noStrike" u="none">
               <a:solidFill>
@@ -11498,7 +11498,7 @@
                 <a:latin typeface="Aptos"/>
                 <a:ea typeface="Aptos"/>
               </a:rPr>
-              <a:t>• Relato: avaliar o percurso de pensamento, não apenas o código final.</a:t>
+              <a:t>Avaliar o percurso de pensamento, não apenas o código final.</a:t>
             </a:r>
             <a:endParaRPr b="0" lang="pt-BR" sz="1100" strike="noStrike" u="none">
               <a:solidFill>
@@ -12624,7 +12624,7 @@
                 <a:latin typeface="Aptos"/>
                 <a:ea typeface="Aptos"/>
               </a:rPr>
-              <a:t>• Relato: solicitar explicação do raciocínio desenvolvido.</a:t>
+              <a:t>Solicitar explicação do raciocínio desenvolvido.</a:t>
             </a:r>
             <a:endParaRPr b="0" lang="pt-BR" sz="1100" strike="noStrike" u="none">
               <a:solidFill>
@@ -12651,7 +12651,7 @@
                 <a:latin typeface="Aptos"/>
                 <a:ea typeface="Aptos"/>
               </a:rPr>
-              <a:t>• Queiroz: feedback visual/textual deve orientar interpretação, não apenas corrigir.</a:t>
+              <a:t>Feedback visual/textual deve orientar interpretação, não apenas corrigir.</a:t>
             </a:r>
             <a:endParaRPr b="0" lang="pt-BR" sz="1100" strike="noStrike" u="none">
               <a:solidFill>
@@ -12678,7 +12678,7 @@
                 <a:latin typeface="Aptos"/>
                 <a:ea typeface="Aptos"/>
               </a:rPr>
-              <a:t>• Wessels: atividades planejadas desenvolvem representação e pensamento de ordem superior.</a:t>
+              <a:t>Atividades planejadas desenvolvem representação e pensamento de ordem superior.</a:t>
             </a:r>
             <a:endParaRPr b="0" lang="pt-BR" sz="1100" strike="noStrike" u="none">
               <a:solidFill>
@@ -13804,7 +13804,7 @@
                 <a:latin typeface="Aptos"/>
                 <a:ea typeface="Aptos"/>
               </a:rPr>
-              <a:t>• Queiroz: feedback visual/textual deve orientar interpretação, não apenas corrigir.</a:t>
+              <a:t>Feedback visual/textual deve orientar interpretação, não apenas corrigir.</a:t>
             </a:r>
             <a:endParaRPr b="0" lang="pt-BR" sz="1050" strike="noStrike" u="none">
               <a:solidFill>
@@ -13831,7 +13831,7 @@
                 <a:latin typeface="Aptos"/>
                 <a:ea typeface="Aptos"/>
               </a:rPr>
-              <a:t>• Relato: incluir revisão, depuração e reconstrução.</a:t>
+              <a:t>Incluir revisão, depuração e reconstrução.</a:t>
             </a:r>
             <a:endParaRPr b="0" lang="pt-BR" sz="1050" strike="noStrike" u="none">
               <a:solidFill>
@@ -13858,7 +13858,7 @@
                 <a:latin typeface="Aptos"/>
                 <a:ea typeface="Aptos"/>
               </a:rPr>
-              <a:t>• Wessels: respostas idiossincráticas também revelam modos de pensar.</a:t>
+              <a:t>Respostas idiossincráticas também revelam modos de pensar.</a:t>
             </a:r>
             <a:endParaRPr b="0" lang="pt-BR" sz="1050" strike="noStrike" u="none">
               <a:solidFill>
@@ -14984,7 +14984,7 @@
                 <a:latin typeface="Aptos"/>
                 <a:ea typeface="Aptos"/>
               </a:rPr>
-              <a:t>• Relato: avaliar o percurso de pensamento, não apenas o código final.</a:t>
+              <a:t>Avaliar o percurso de pensamento, não apenas o código final.</a:t>
             </a:r>
             <a:endParaRPr b="0" lang="pt-BR" sz="1100" strike="noStrike" u="none">
               <a:solidFill>
@@ -15011,7 +15011,7 @@
                 <a:latin typeface="Aptos"/>
                 <a:ea typeface="Aptos"/>
               </a:rPr>
-              <a:t>• Queiroz: o percurso da tarefa revela mudanças no discurso e na ação.</a:t>
+              <a:t>O percurso da tarefa revela mudanças no discurso e na ação.</a:t>
             </a:r>
             <a:endParaRPr b="0" lang="pt-BR" sz="1100" strike="noStrike" u="none">
               <a:solidFill>
@@ -15038,7 +15038,7 @@
                 <a:latin typeface="Aptos"/>
                 <a:ea typeface="Aptos"/>
               </a:rPr>
-              <a:t>• Wessels: atividades planejadas desenvolvem representação e pensamento de ordem superior.</a:t>
+              <a:t>Atividades planejadas desenvolvem representação e pensamento de ordem superior.</a:t>
             </a:r>
             <a:endParaRPr b="0" lang="pt-BR" sz="1100" strike="noStrike" u="none">
               <a:solidFill>

</xml_diff>